<commit_message>
Add session 9-22 student decks and rework session 9 with Lovable LP
Generate 受講者用 versions (no 講師用 label) for sessions 9 through 22
(basic + applied = 28 files). Rework session 9 to start with Lovable LP
vibe coding as exercise 1, keeping 公式LINE AIDMA design as exercise 2,
and shifting rich-menu image generation to the applied edition.

https://claude.ai/code/session_01MLnStsm4YQNeGye3rc2BGH
</commit_message>
<xml_diff>
--- a/pptx_sessions_8_22/第9回_基礎編_講師用.pptx
+++ b/pptx_sessions_8_22/第9回_基礎編_講師用.pptx
@@ -1675,7 +1675,7 @@
                 <a:ea typeface="Yu Gothic UI" pitchFamily="34" charset="-122"/>
                 <a:cs typeface="Yu Gothic UI" pitchFamily="34" charset="-120"/>
               </a:rPr>
-              <a:t>〜 公式LINEの構成設計と集客導線の作り方 〜</a:t>
+              <a:t>〜 Lovable で LP をバイブコーディング+公式LINE 構成設計 〜</a:t>
             </a:r>
             <a:endParaRPr lang="en-US" sz="2400" dirty="0"/>
           </a:p>
@@ -1945,7 +1945,7 @@
                 <a:ea typeface="Yu Gothic UI" pitchFamily="34" charset="-122"/>
                 <a:cs typeface="Yu Gothic UI" pitchFamily="34" charset="-120"/>
               </a:rPr>
-              <a:t>公式LINEを「集客の入口」から「商談予約」までの導線として設計します。</a:t>
+              <a:t>Lovable で LP を自分でバイブコーディングし、その後 公式LINE の構成を AIDMA で設計します。</a:t>
             </a:r>
             <a:endParaRPr lang="en-US" sz="2000" dirty="0"/>
           </a:p>
@@ -2054,7 +2054,7 @@
                 <a:ea typeface="Yu Gothic UI" pitchFamily="34" charset="-122"/>
                 <a:cs typeface="Yu Gothic UI" pitchFamily="34" charset="-120"/>
               </a:rPr>
-              <a:t>公式LINEの全体構成を設計</a:t>
+              <a:t>Lovable で LP を作る</a:t>
             </a:r>
             <a:endParaRPr lang="en-US" sz="2400" dirty="0"/>
           </a:p>
@@ -2093,7 +2093,7 @@
                 <a:ea typeface="Yu Gothic UI" pitchFamily="34" charset="-122"/>
                 <a:cs typeface="Yu Gothic UI" pitchFamily="34" charset="-120"/>
               </a:rPr>
-              <a:t>AIDMAの法則に沿って動線を作る</a:t>
+              <a:t>AIに頼んでLPをバイブコーディング</a:t>
             </a:r>
             <a:endParaRPr lang="en-US" sz="2000" dirty="0"/>
           </a:p>
@@ -2202,7 +2202,7 @@
                 <a:ea typeface="Yu Gothic UI" pitchFamily="34" charset="-122"/>
                 <a:cs typeface="Yu Gothic UI" pitchFamily="34" charset="-120"/>
               </a:rPr>
-              <a:t>リッチメニュー+アイコンを作成</a:t>
+              <a:t>公式LINE の構成を設計</a:t>
             </a:r>
             <a:endParaRPr lang="en-US" sz="2400" dirty="0"/>
           </a:p>
@@ -2241,7 +2241,7 @@
                 <a:ea typeface="Yu Gothic UI" pitchFamily="34" charset="-122"/>
                 <a:cs typeface="Yu Gothic UI" pitchFamily="34" charset="-120"/>
               </a:rPr>
-              <a:t>AIで画像生成までやってみる</a:t>
+              <a:t>AIDMA で動線を組み立てる</a:t>
             </a:r>
             <a:endParaRPr lang="en-US" sz="2000" dirty="0"/>
           </a:p>
@@ -2389,7 +2389,7 @@
                 <a:ea typeface="Yu Gothic UI" pitchFamily="34" charset="-122"/>
                 <a:cs typeface="Yu Gothic UI" pitchFamily="34" charset="-120"/>
               </a:rPr>
-              <a:t>Lステップの構造理解だけでも体験</a:t>
+              <a:t>LP/LINE の現状棚卸しから</a:t>
             </a:r>
             <a:endParaRPr lang="en-US" sz="2000" dirty="0"/>
           </a:p>
@@ -3044,7 +3044,7 @@
                 <a:ea typeface="Yu Gothic UI" pitchFamily="34" charset="-122"/>
                 <a:cs typeface="Yu Gothic UI" pitchFamily="34" charset="-120"/>
               </a:rPr>
-              <a:t>前回の振り返り(WEBブランディングの3軸)</a:t>
+              <a:t>前回の振り返り(WEBブランディング3軸)</a:t>
             </a:r>
             <a:endParaRPr lang="en-US" sz="2000" dirty="0"/>
           </a:p>
@@ -3184,7 +3184,7 @@
                 <a:ea typeface="Yu Gothic UI" pitchFamily="34" charset="-122"/>
                 <a:cs typeface="Yu Gothic UI" pitchFamily="34" charset="-120"/>
               </a:rPr>
-              <a:t>公式LINEの基本構成をAIDMAで設計する</a:t>
+              <a:t>Lovable で LP をバイブコーディング</a:t>
             </a:r>
             <a:endParaRPr lang="en-US" sz="2000" dirty="0"/>
           </a:p>
@@ -3324,7 +3324,7 @@
                 <a:ea typeface="Yu Gothic UI" pitchFamily="34" charset="-122"/>
                 <a:cs typeface="Yu Gothic UI" pitchFamily="34" charset="-120"/>
               </a:rPr>
-              <a:t>公式LINEとLステップの違い・使い分け</a:t>
+              <a:t>LP→公式LINE→面談予約 の動線設計</a:t>
             </a:r>
             <a:endParaRPr lang="en-US" sz="2000" dirty="0"/>
           </a:p>
@@ -3464,7 +3464,7 @@
                 <a:ea typeface="Yu Gothic UI" pitchFamily="34" charset="-122"/>
                 <a:cs typeface="Yu Gothic UI" pitchFamily="34" charset="-120"/>
               </a:rPr>
-              <a:t>リッチメニュー+アイコン画像をAIで作成</a:t>
+              <a:t>公式LINE の構成を AIDMA で設計</a:t>
             </a:r>
             <a:endParaRPr lang="en-US" sz="2000" dirty="0"/>
           </a:p>
@@ -3604,7 +3604,7 @@
                 <a:ea typeface="Yu Gothic UI" pitchFamily="34" charset="-122"/>
                 <a:cs typeface="Yu Gothic UI" pitchFamily="34" charset="-120"/>
               </a:rPr>
-              <a:t>【基礎組】既存LINE/SNSの導線を棚卸し</a:t>
+              <a:t>【基礎組】今のLP/LINE/SNSの導線を棚卸し</a:t>
             </a:r>
             <a:endParaRPr lang="en-US" sz="2000" dirty="0"/>
           </a:p>
@@ -3874,7 +3874,7 @@
                 <a:ea typeface="Yu Gothic UI" pitchFamily="34" charset="-122"/>
                 <a:cs typeface="Yu Gothic UI" pitchFamily="34" charset="-120"/>
               </a:rPr>
-              <a:t>第8回でブランディング3軸ができた前提で、その3軸を活かす「公式LINE」を設計します。</a:t>
+              <a:t>第8回でブランディング3軸ができた前提で、その3軸を活かす「LPと公式LINE」を作ります。</a:t>
             </a:r>
             <a:endParaRPr lang="en-US" sz="2200" dirty="0"/>
           </a:p>
@@ -4119,7 +4119,7 @@
                 <a:ea typeface="Yu Gothic UI" pitchFamily="34" charset="-122"/>
                 <a:cs typeface="Yu Gothic UI" pitchFamily="34" charset="-120"/>
               </a:rPr>
-              <a:t>   3軸を活かして、公式LINEで「集客→教育→商談予約」の導線を作る</a:t>
+              <a:t>   3軸を反映した LP を Lovable で「バイブコーディング」して作る</a:t>
             </a:r>
             <a:endParaRPr lang="en-US" sz="2000" dirty="0"/>
           </a:p>
@@ -4136,7 +4136,7 @@
                 <a:ea typeface="Yu Gothic UI" pitchFamily="34" charset="-122"/>
                 <a:cs typeface="Yu Gothic UI" pitchFamily="34" charset="-120"/>
               </a:rPr>
-              <a:t>   AIDMAの法則をベースに構成を設計する</a:t>
+              <a:t>   公式LINE の構成を AIDMA に沿って設計し、LP→LINE→面談予約の動線を繋ぐ</a:t>
             </a:r>
             <a:endParaRPr lang="en-US" sz="2000" dirty="0"/>
           </a:p>
@@ -4367,7 +4367,7 @@
                 <a:ea typeface="Yu Gothic UI" pitchFamily="34" charset="-122"/>
                 <a:cs typeface="Yu Gothic UI" pitchFamily="34" charset="-120"/>
               </a:rPr>
-              <a:t>公式LINEの構成をAIDMAで設計する</a:t>
+              <a:t>Lovable で LP をバイブコーディング</a:t>
             </a:r>
             <a:endParaRPr lang="en-US" sz="2600" dirty="0"/>
           </a:p>
@@ -4406,7 +4406,7 @@
                 <a:ea typeface="Yu Gothic UI" pitchFamily="34" charset="-122"/>
                 <a:cs typeface="Yu Gothic UI" pitchFamily="34" charset="-120"/>
               </a:rPr>
-              <a:t>注目→興味→欲求→記憶→行動の5段階で、LINEの構成をAIと設計します。</a:t>
+              <a:t>Lovable(AIノーコードツール)に日本語で頼むだけで、3軸を反映した LP を作ります。</a:t>
             </a:r>
             <a:endParaRPr lang="en-US" sz="2000" dirty="0"/>
           </a:p>
@@ -4554,7 +4554,7 @@
                 <a:ea typeface="Yu Gothic UI" pitchFamily="34" charset="-122"/>
                 <a:cs typeface="Yu Gothic UI" pitchFamily="34" charset="-120"/>
               </a:rPr>
-              <a:t>公式LINEは作ったが、登録者が増えない／登録後の動線が決まっていない。</a:t>
+              <a:t>LPがあるとよく聞くが、Web制作の知識がなくて作れていない。3軸も整理できたので形にしたい。</a:t>
             </a:r>
             <a:endParaRPr lang="en-US" sz="2000" dirty="0"/>
           </a:p>
@@ -4632,7 +4632,7 @@
                 <a:ea typeface="Yu Gothic UI" pitchFamily="34" charset="-122"/>
                 <a:cs typeface="Yu Gothic UI" pitchFamily="34" charset="-120"/>
               </a:rPr>
-              <a:t>AIDMA別の構成設計シート(各段階で「何を見せる」「何を聞く」を整理)</a:t>
+              <a:t>3軸とAIDMAの構成を反映した LP(公開URL付き、公式LINE登録ボタン入り)</a:t>
             </a:r>
             <a:endParaRPr lang="en-US" sz="2000" dirty="0"/>
           </a:p>
@@ -4710,7 +4710,7 @@
                 <a:ea typeface="Yu Gothic UI" pitchFamily="34" charset="-122"/>
                 <a:cs typeface="Yu Gothic UI" pitchFamily="34" charset="-120"/>
               </a:rPr>
-              <a:t>各段階1行で書く／自分のブランディング3軸に沿う／LINE特有の動線(リッチメニュー・ステップ配信)を意識</a:t>
+              <a:t>Lovable を使う／プロンプトは「ブランディング3軸+ターゲット+CTA」を全部書く／文字量は読みやすさ優先</a:t>
             </a:r>
             <a:endParaRPr lang="en-US" sz="2000" dirty="0"/>
           </a:p>
@@ -4819,7 +4819,7 @@
                 <a:ea typeface="Yu Gothic UI" pitchFamily="34" charset="-122"/>
                 <a:cs typeface="Yu Gothic UI" pitchFamily="34" charset="-120"/>
               </a:rPr>
-              <a:t>1. Gemini に「保険営業の公式LINEをAIDMAで構成して」と依頼</a:t>
+              <a:t>1. Lovable にログイン →「新規プロジェクト」→ 第8回で作った3軸とターゲットを伝えて LP を依頼</a:t>
             </a:r>
             <a:endParaRPr lang="en-US" sz="2000" dirty="0"/>
           </a:p>
@@ -4858,7 +4858,7 @@
                 <a:ea typeface="Yu Gothic UI" pitchFamily="34" charset="-122"/>
                 <a:cs typeface="Yu Gothic UI" pitchFamily="34" charset="-120"/>
               </a:rPr>
-              <a:t>2. 自分の3軸と現状(登録者数・配信頻度)を伝える</a:t>
+              <a:t>2. 生成された LP の文言・色味・画像を、Lovable に追加指示しながら修正(バイブコーディング)</a:t>
             </a:r>
             <a:endParaRPr lang="en-US" sz="2000" dirty="0"/>
           </a:p>
@@ -4897,7 +4897,7 @@
                 <a:ea typeface="Yu Gothic UI" pitchFamily="34" charset="-122"/>
                 <a:cs typeface="Yu Gothic UI" pitchFamily="34" charset="-120"/>
               </a:rPr>
-              <a:t>3. 出力された構成案をスプシで一覧化し、優先順位を付ける</a:t>
+              <a:t>3. 公式LINE 登録ボタンを設置 → デプロイして公開URLを取得</a:t>
             </a:r>
             <a:endParaRPr lang="en-US" sz="2000" dirty="0"/>
           </a:p>
@@ -5128,7 +5128,7 @@
                 <a:ea typeface="Yu Gothic UI" pitchFamily="34" charset="-122"/>
                 <a:cs typeface="Yu Gothic UI" pitchFamily="34" charset="-120"/>
               </a:rPr>
-              <a:t>公式LINE / Lステップ / メルマガの違い</a:t>
+              <a:t>LP→公式LINE→面談予約 の動線設計</a:t>
             </a:r>
             <a:endParaRPr lang="en-US" sz="2600" dirty="0"/>
           </a:p>
@@ -5167,7 +5167,7 @@
                 <a:ea typeface="Yu Gothic UI" pitchFamily="34" charset="-122"/>
                 <a:cs typeface="Yu Gothic UI" pitchFamily="34" charset="-120"/>
               </a:rPr>
-              <a:t>どのツールを使うかで設計が変わります。違いと使い分けを整理します。</a:t>
+              <a:t>「来てくれた人」を「面談予約」まで連れていく動線を設計します。</a:t>
             </a:r>
             <a:endParaRPr lang="en-US" sz="2200" dirty="0"/>
           </a:p>
@@ -5237,7 +5237,7 @@
                 <a:ea typeface="Yu Gothic UI" pitchFamily="34" charset="-122"/>
                 <a:cs typeface="Yu Gothic UI" pitchFamily="34" charset="-120"/>
               </a:rPr>
-              <a:t>ツール比較と使い分け</a:t>
+              <a:t>集客動線の3段階</a:t>
             </a:r>
             <a:endParaRPr lang="en-US" sz="2200" dirty="0"/>
           </a:p>
@@ -5276,7 +5276,7 @@
                 <a:ea typeface="Yu Gothic UI" pitchFamily="34" charset="-122"/>
                 <a:cs typeface="Yu Gothic UI" pitchFamily="34" charset="-120"/>
               </a:rPr>
-              <a:t>【公式LINE(無料/有料プラン)】</a:t>
+              <a:t>【1段階目: LP】</a:t>
             </a:r>
             <a:endParaRPr lang="en-US" sz="2000" dirty="0"/>
           </a:p>
@@ -5293,7 +5293,7 @@
                 <a:ea typeface="Yu Gothic UI" pitchFamily="34" charset="-122"/>
                 <a:cs typeface="Yu Gothic UI" pitchFamily="34" charset="-120"/>
               </a:rPr>
-              <a:t>   ・配信通数に上限あり／タグ管理が限定的</a:t>
+              <a:t>   ・3軸を伝える1ページ(自己紹介+価値+CTA)</a:t>
             </a:r>
             <a:endParaRPr lang="en-US" sz="2000" dirty="0"/>
           </a:p>
@@ -5310,7 +5310,7 @@
                 <a:ea typeface="Yu Gothic UI" pitchFamily="34" charset="-122"/>
                 <a:cs typeface="Yu Gothic UI" pitchFamily="34" charset="-120"/>
               </a:rPr>
-              <a:t>   ・最初の検証フェーズに向く</a:t>
+              <a:t>   ・SNS/広告/紹介からの着地点</a:t>
             </a:r>
             <a:endParaRPr lang="en-US" sz="2000" dirty="0"/>
           </a:p>
@@ -5327,6 +5327,23 @@
                 <a:ea typeface="Yu Gothic UI" pitchFamily="34" charset="-122"/>
                 <a:cs typeface="Yu Gothic UI" pitchFamily="34" charset="-120"/>
               </a:rPr>
+              <a:t>   ・CTAは「公式LINE登録」一択にする</a:t>
+            </a:r>
+            <a:endParaRPr lang="en-US" sz="2000" dirty="0"/>
+          </a:p>
+          <a:p>
+            <a:pPr indent="0" marL="0">
+              <a:buNone/>
+            </a:pPr>
+            <a:r>
+              <a:rPr lang="en-US" sz="2000" dirty="0">
+                <a:solidFill>
+                  <a:srgbClr val="222222"/>
+                </a:solidFill>
+                <a:latin typeface="Yu Gothic UI" pitchFamily="34" charset="0"/>
+                <a:ea typeface="Yu Gothic UI" pitchFamily="34" charset="-122"/>
+                <a:cs typeface="Yu Gothic UI" pitchFamily="34" charset="-120"/>
+              </a:rPr>
               <a:t/>
             </a:r>
             <a:endParaRPr lang="en-US" sz="2000" dirty="0"/>
@@ -5344,7 +5361,7 @@
                 <a:ea typeface="Yu Gothic UI" pitchFamily="34" charset="-122"/>
                 <a:cs typeface="Yu Gothic UI" pitchFamily="34" charset="-120"/>
               </a:rPr>
-              <a:t>【Lステップ(外部ツール)】</a:t>
+              <a:t>【2段階目: 公式LINE】</a:t>
             </a:r>
             <a:endParaRPr lang="en-US" sz="2000" dirty="0"/>
           </a:p>
@@ -5361,7 +5378,7 @@
                 <a:ea typeface="Yu Gothic UI" pitchFamily="34" charset="-122"/>
                 <a:cs typeface="Yu Gothic UI" pitchFamily="34" charset="-120"/>
               </a:rPr>
-              <a:t>   ・ステップ配信・タグ管理・流入経路分析が強力</a:t>
+              <a:t>   ・登録直後のあいさつ+ステップ配信で関係構築</a:t>
             </a:r>
             <a:endParaRPr lang="en-US" sz="2000" dirty="0"/>
           </a:p>
@@ -5378,7 +5395,7 @@
                 <a:ea typeface="Yu Gothic UI" pitchFamily="34" charset="-122"/>
                 <a:cs typeface="Yu Gothic UI" pitchFamily="34" charset="-120"/>
               </a:rPr>
-              <a:t>   ・本格運用フェーズに向く</a:t>
+              <a:t>   ・興味度が上がったら面談予約へ誘導</a:t>
             </a:r>
             <a:endParaRPr lang="en-US" sz="2000" dirty="0"/>
           </a:p>
@@ -5395,6 +5412,23 @@
                 <a:ea typeface="Yu Gothic UI" pitchFamily="34" charset="-122"/>
                 <a:cs typeface="Yu Gothic UI" pitchFamily="34" charset="-120"/>
               </a:rPr>
+              <a:t>   ・AIDMA(注目→興味→欲求→記憶→行動)に沿って設計</a:t>
+            </a:r>
+            <a:endParaRPr lang="en-US" sz="2000" dirty="0"/>
+          </a:p>
+          <a:p>
+            <a:pPr indent="0" marL="0">
+              <a:buNone/>
+            </a:pPr>
+            <a:r>
+              <a:rPr lang="en-US" sz="2000" dirty="0">
+                <a:solidFill>
+                  <a:srgbClr val="222222"/>
+                </a:solidFill>
+                <a:latin typeface="Yu Gothic UI" pitchFamily="34" charset="0"/>
+                <a:ea typeface="Yu Gothic UI" pitchFamily="34" charset="-122"/>
+                <a:cs typeface="Yu Gothic UI" pitchFamily="34" charset="-120"/>
+              </a:rPr>
               <a:t/>
             </a:r>
             <a:endParaRPr lang="en-US" sz="2000" dirty="0"/>
@@ -5412,7 +5446,7 @@
                 <a:ea typeface="Yu Gothic UI" pitchFamily="34" charset="-122"/>
                 <a:cs typeface="Yu Gothic UI" pitchFamily="34" charset="-120"/>
               </a:rPr>
-              <a:t>【メルマガ】</a:t>
+              <a:t>【3段階目: 面談予約】</a:t>
             </a:r>
             <a:endParaRPr lang="en-US" sz="2000" dirty="0"/>
           </a:p>
@@ -5429,7 +5463,7 @@
                 <a:ea typeface="Yu Gothic UI" pitchFamily="34" charset="-122"/>
                 <a:cs typeface="Yu Gothic UI" pitchFamily="34" charset="-120"/>
               </a:rPr>
-              <a:t>   ・到達率は LINE より低いが、長文向き</a:t>
+              <a:t>   ・第8回で作ったアイテマスへ誘導</a:t>
             </a:r>
             <a:endParaRPr lang="en-US" sz="2000" dirty="0"/>
           </a:p>
@@ -5446,7 +5480,7 @@
                 <a:ea typeface="Yu Gothic UI" pitchFamily="34" charset="-122"/>
                 <a:cs typeface="Yu Gothic UI" pitchFamily="34" charset="-120"/>
               </a:rPr>
-              <a:t>   ・補助的に併用すると安定</a:t>
+              <a:t>   ・「無料相談」など心理的ハードルを下げる名前</a:t>
             </a:r>
             <a:endParaRPr lang="en-US" sz="2000" dirty="0"/>
           </a:p>
@@ -5480,7 +5514,7 @@
                 <a:ea typeface="Yu Gothic UI" pitchFamily="34" charset="-122"/>
                 <a:cs typeface="Yu Gothic UI" pitchFamily="34" charset="-120"/>
               </a:rPr>
-              <a:t>【選び方の目安】</a:t>
+              <a:t>【ポイント】</a:t>
             </a:r>
             <a:endParaRPr lang="en-US" sz="2000" dirty="0"/>
           </a:p>
@@ -5497,7 +5531,7 @@
                 <a:ea typeface="Yu Gothic UI" pitchFamily="34" charset="-122"/>
                 <a:cs typeface="Yu Gothic UI" pitchFamily="34" charset="-120"/>
               </a:rPr>
-              <a:t>   ・登録者100人未満 → まず公式LINE</a:t>
+              <a:t>   ・各段階を1個のCTAに絞る(選択肢を増やすと離脱する)</a:t>
             </a:r>
             <a:endParaRPr lang="en-US" sz="2000" dirty="0"/>
           </a:p>
@@ -5514,7 +5548,7 @@
                 <a:ea typeface="Yu Gothic UI" pitchFamily="34" charset="-122"/>
                 <a:cs typeface="Yu Gothic UI" pitchFamily="34" charset="-120"/>
               </a:rPr>
-              <a:t>   ・100人超 → Lステップ導入を検討</a:t>
+              <a:t>   ・LP→LINE は QR+URL の両方で導線を作る</a:t>
             </a:r>
             <a:endParaRPr lang="en-US" sz="2000" dirty="0"/>
           </a:p>
@@ -5745,7 +5779,7 @@
                 <a:ea typeface="Yu Gothic UI" pitchFamily="34" charset="-122"/>
                 <a:cs typeface="Yu Gothic UI" pitchFamily="34" charset="-120"/>
               </a:rPr>
-              <a:t>リッチメニュー+アイコンをAIで作る</a:t>
+              <a:t>公式LINE の構成を AIDMA で設計</a:t>
             </a:r>
             <a:endParaRPr lang="en-US" sz="2600" dirty="0"/>
           </a:p>
@@ -5784,7 +5818,7 @@
                 <a:ea typeface="Yu Gothic UI" pitchFamily="34" charset="-122"/>
                 <a:cs typeface="Yu Gothic UI" pitchFamily="34" charset="-120"/>
               </a:rPr>
-              <a:t>AIで画像を生成して、ブランディング3軸に沿ったリッチメニューを作ります。</a:t>
+              <a:t>注目→興味→欲求→記憶→行動の5段階で、LINE の構成を AI と設計します。</a:t>
             </a:r>
             <a:endParaRPr lang="en-US" sz="2000" dirty="0"/>
           </a:p>
@@ -5932,7 +5966,7 @@
                 <a:ea typeface="Yu Gothic UI" pitchFamily="34" charset="-122"/>
                 <a:cs typeface="Yu Gothic UI" pitchFamily="34" charset="-120"/>
               </a:rPr>
-              <a:t>リッチメニューは作ったほうがいいと聞くが、デザインの作り方が分からない。</a:t>
+              <a:t>公式LINE は作ったが、登録者の動線が決まっていない。LP からの流入も活かせていない。</a:t>
             </a:r>
             <a:endParaRPr lang="en-US" sz="2000" dirty="0"/>
           </a:p>
@@ -6010,7 +6044,7 @@
                 <a:ea typeface="Yu Gothic UI" pitchFamily="34" charset="-122"/>
                 <a:cs typeface="Yu Gothic UI" pitchFamily="34" charset="-120"/>
               </a:rPr>
-              <a:t>AI生成画像を使ったリッチメニュー1枚(6分割または4分割)+ アイコン画像</a:t>
+              <a:t>AIDMA別の構成設計シート(各段階で「何を見せる」「何を聞く」を整理)</a:t>
             </a:r>
             <a:endParaRPr lang="en-US" sz="2000" dirty="0"/>
           </a:p>
@@ -6088,7 +6122,7 @@
                 <a:ea typeface="Yu Gothic UI" pitchFamily="34" charset="-122"/>
                 <a:cs typeface="Yu Gothic UI" pitchFamily="34" charset="-120"/>
               </a:rPr>
-              <a:t>画像生成は Gemini / Genspark / Canva 等のいずれか／3軸のトーンに合わせる／文字は最小限</a:t>
+              <a:t>各段階1行で書く／自分のブランディング3軸に沿う／LINE特有の動線(リッチメニュー・ステップ配信)を意識</a:t>
             </a:r>
             <a:endParaRPr lang="en-US" sz="2000" dirty="0"/>
           </a:p>
@@ -6197,7 +6231,7 @@
                 <a:ea typeface="Yu Gothic UI" pitchFamily="34" charset="-122"/>
                 <a:cs typeface="Yu Gothic UI" pitchFamily="34" charset="-120"/>
               </a:rPr>
-              <a:t>1. Gemini に「3軸を踏まえたリッチメニューのレイアウト案」を出してもらう</a:t>
+              <a:t>1. Gemini に「保険営業の公式LINEを AIDMA で構成して」と依頼</a:t>
             </a:r>
             <a:endParaRPr lang="en-US" sz="2000" dirty="0"/>
           </a:p>
@@ -6236,7 +6270,7 @@
                 <a:ea typeface="Yu Gothic UI" pitchFamily="34" charset="-122"/>
                 <a:cs typeface="Yu Gothic UI" pitchFamily="34" charset="-120"/>
               </a:rPr>
-              <a:t>2. 画像生成AIで背景画像・アイコンを生成</a:t>
+              <a:t>2. 自分の3軸と LP の URL を共有して構成を組ませる</a:t>
             </a:r>
             <a:endParaRPr lang="en-US" sz="2000" dirty="0"/>
           </a:p>
@@ -6275,7 +6309,7 @@
                 <a:ea typeface="Yu Gothic UI" pitchFamily="34" charset="-122"/>
                 <a:cs typeface="Yu Gothic UI" pitchFamily="34" charset="-120"/>
               </a:rPr>
-              <a:t>3. Canva 等でリッチメニュー画像を組み立てて公式LINEにアップロード</a:t>
+              <a:t>3. 出力された構成案をスプシで一覧化し、優先順位を付ける</a:t>
             </a:r>
             <a:endParaRPr lang="en-US" sz="2000" dirty="0"/>
           </a:p>
@@ -6506,7 +6540,7 @@
                 <a:ea typeface="Yu Gothic UI" pitchFamily="34" charset="-122"/>
                 <a:cs typeface="Yu Gothic UI" pitchFamily="34" charset="-120"/>
               </a:rPr>
-              <a:t>【基礎組】既存LINE/SNSの導線を棚卸し</a:t>
+              <a:t>【基礎組】今のLP/LINE/SNSの導線を棚卸し</a:t>
             </a:r>
             <a:endParaRPr lang="en-US" sz="2600" dirty="0"/>
           </a:p>
@@ -6693,7 +6727,7 @@
                 <a:ea typeface="Yu Gothic UI" pitchFamily="34" charset="-122"/>
                 <a:cs typeface="Yu Gothic UI" pitchFamily="34" charset="-120"/>
               </a:rPr>
-              <a:t>公式LINEはあるが、そこに人がどう来てどう動いているかを把握できていない。</a:t>
+              <a:t>LP/LINE/SNS は持っているが、それぞれがどう繋がっているか把握できていない。</a:t>
             </a:r>
             <a:endParaRPr lang="en-US" sz="2000" dirty="0"/>
           </a:p>
@@ -6958,7 +6992,7 @@
                 <a:ea typeface="Yu Gothic UI" pitchFamily="34" charset="-122"/>
                 <a:cs typeface="Yu Gothic UI" pitchFamily="34" charset="-120"/>
               </a:rPr>
-              <a:t>1. 過去3ヶ月の登録者の流入元を思い出す/データで確認</a:t>
+              <a:t>1. 過去3ヶ月の流入元を思い出す/データで確認</a:t>
             </a:r>
             <a:endParaRPr lang="en-US" sz="2000" dirty="0"/>
           </a:p>

</xml_diff>